<commit_message>
Fix Create trips functionality
</commit_message>
<xml_diff>
--- a/Data/CarpoolingApp PRESENTATION.pptx
+++ b/Data/CarpoolingApp PRESENTATION.pptx
@@ -10,7 +10,10 @@
     <p:sldId id="258" r:id="rId4"/>
     <p:sldId id="259" r:id="rId5"/>
     <p:sldId id="260" r:id="rId6"/>
-    <p:sldId id="261" r:id="rId7"/>
+    <p:sldId id="262" r:id="rId7"/>
+    <p:sldId id="263" r:id="rId8"/>
+    <p:sldId id="264" r:id="rId9"/>
+    <p:sldId id="261" r:id="rId10"/>
   </p:sldIdLst>
   <p:sldSz cx="12192000" cy="6858000"/>
   <p:notesSz cx="6858000" cy="9144000"/>
@@ -109,6 +112,11 @@
       </a:defRPr>
     </a:lvl9pPr>
   </p:defaultTextStyle>
+  <p:extLst>
+    <p:ext uri="{EFAFB233-063F-42B5-8137-9DF3F51BA10A}">
+      <p15:sldGuideLst xmlns:p15="http://schemas.microsoft.com/office/powerpoint/2012/main"/>
+    </p:ext>
+  </p:extLst>
 </p:presentation>
 </file>
 
@@ -308,7 +316,7 @@
           <a:p>
             <a:fld id="{A248BCF7-5193-4BDA-BA8C-9A8BE3A094DD}" type="datetimeFigureOut">
               <a:rPr lang="bg-BG" smtClean="0"/>
-              <a:t>23.4.2026 г.</a:t>
+              <a:t>28.4.2026 г.</a:t>
             </a:fld>
             <a:endParaRPr lang="bg-BG"/>
           </a:p>
@@ -532,7 +540,7 @@
           <a:p>
             <a:fld id="{A248BCF7-5193-4BDA-BA8C-9A8BE3A094DD}" type="datetimeFigureOut">
               <a:rPr lang="bg-BG" smtClean="0"/>
-              <a:t>23.4.2026 г.</a:t>
+              <a:t>28.4.2026 г.</a:t>
             </a:fld>
             <a:endParaRPr lang="bg-BG"/>
           </a:p>
@@ -712,7 +720,7 @@
           <a:p>
             <a:fld id="{A248BCF7-5193-4BDA-BA8C-9A8BE3A094DD}" type="datetimeFigureOut">
               <a:rPr lang="bg-BG" smtClean="0"/>
-              <a:t>23.4.2026 г.</a:t>
+              <a:t>28.4.2026 г.</a:t>
             </a:fld>
             <a:endParaRPr lang="bg-BG"/>
           </a:p>
@@ -882,7 +890,7 @@
           <a:p>
             <a:fld id="{A248BCF7-5193-4BDA-BA8C-9A8BE3A094DD}" type="datetimeFigureOut">
               <a:rPr lang="bg-BG" smtClean="0"/>
-              <a:t>23.4.2026 г.</a:t>
+              <a:t>28.4.2026 г.</a:t>
             </a:fld>
             <a:endParaRPr lang="bg-BG"/>
           </a:p>
@@ -1173,7 +1181,7 @@
           <a:p>
             <a:fld id="{A248BCF7-5193-4BDA-BA8C-9A8BE3A094DD}" type="datetimeFigureOut">
               <a:rPr lang="bg-BG" smtClean="0"/>
-              <a:t>23.4.2026 г.</a:t>
+              <a:t>28.4.2026 г.</a:t>
             </a:fld>
             <a:endParaRPr lang="bg-BG"/>
           </a:p>
@@ -1499,7 +1507,7 @@
           <a:p>
             <a:fld id="{A248BCF7-5193-4BDA-BA8C-9A8BE3A094DD}" type="datetimeFigureOut">
               <a:rPr lang="bg-BG" smtClean="0"/>
-              <a:t>23.4.2026 г.</a:t>
+              <a:t>28.4.2026 г.</a:t>
             </a:fld>
             <a:endParaRPr lang="bg-BG"/>
           </a:p>
@@ -1911,7 +1919,7 @@
           <a:p>
             <a:fld id="{A248BCF7-5193-4BDA-BA8C-9A8BE3A094DD}" type="datetimeFigureOut">
               <a:rPr lang="bg-BG" smtClean="0"/>
-              <a:t>23.4.2026 г.</a:t>
+              <a:t>28.4.2026 г.</a:t>
             </a:fld>
             <a:endParaRPr lang="bg-BG"/>
           </a:p>
@@ -2029,7 +2037,7 @@
           <a:p>
             <a:fld id="{A248BCF7-5193-4BDA-BA8C-9A8BE3A094DD}" type="datetimeFigureOut">
               <a:rPr lang="bg-BG" smtClean="0"/>
-              <a:t>23.4.2026 г.</a:t>
+              <a:t>28.4.2026 г.</a:t>
             </a:fld>
             <a:endParaRPr lang="bg-BG"/>
           </a:p>
@@ -2124,7 +2132,7 @@
           <a:p>
             <a:fld id="{A248BCF7-5193-4BDA-BA8C-9A8BE3A094DD}" type="datetimeFigureOut">
               <a:rPr lang="bg-BG" smtClean="0"/>
-              <a:t>23.4.2026 г.</a:t>
+              <a:t>28.4.2026 г.</a:t>
             </a:fld>
             <a:endParaRPr lang="bg-BG"/>
           </a:p>
@@ -2411,7 +2419,7 @@
           <a:p>
             <a:fld id="{A248BCF7-5193-4BDA-BA8C-9A8BE3A094DD}" type="datetimeFigureOut">
               <a:rPr lang="bg-BG" smtClean="0"/>
-              <a:t>23.4.2026 г.</a:t>
+              <a:t>28.4.2026 г.</a:t>
             </a:fld>
             <a:endParaRPr lang="bg-BG"/>
           </a:p>
@@ -2688,7 +2696,7 @@
           <a:p>
             <a:fld id="{A248BCF7-5193-4BDA-BA8C-9A8BE3A094DD}" type="datetimeFigureOut">
               <a:rPr lang="bg-BG" smtClean="0"/>
-              <a:t>23.4.2026 г.</a:t>
+              <a:t>28.4.2026 г.</a:t>
             </a:fld>
             <a:endParaRPr lang="bg-BG"/>
           </a:p>
@@ -2939,7 +2947,7 @@
           <a:p>
             <a:fld id="{A248BCF7-5193-4BDA-BA8C-9A8BE3A094DD}" type="datetimeFigureOut">
               <a:rPr lang="bg-BG" smtClean="0"/>
-              <a:t>23.4.2026 г.</a:t>
+              <a:t>28.4.2026 г.</a:t>
             </a:fld>
             <a:endParaRPr lang="bg-BG"/>
           </a:p>
@@ -3891,7 +3899,7 @@
         </p:nvSpPr>
         <p:spPr>
           <a:xfrm>
-            <a:off x="0" y="-212690"/>
+            <a:off x="308951" y="-262227"/>
             <a:ext cx="9692640" cy="1428929"/>
           </a:xfrm>
         </p:spPr>
@@ -3933,7 +3941,7 @@
         </p:blipFill>
         <p:spPr>
           <a:xfrm>
-            <a:off x="1885518" y="1567638"/>
+            <a:off x="778243" y="1464975"/>
             <a:ext cx="1996200" cy="1856160"/>
           </a:xfrm>
           <a:prstGeom prst="rect">
@@ -3982,7 +3990,7 @@
         </p:blipFill>
         <p:spPr>
           <a:xfrm>
-            <a:off x="4840116" y="1518924"/>
+            <a:off x="3241338" y="1326735"/>
             <a:ext cx="2132640" cy="2132640"/>
           </a:xfrm>
           <a:prstGeom prst="rect">
@@ -4033,7 +4041,7 @@
         </p:blipFill>
         <p:spPr>
           <a:xfrm>
-            <a:off x="7567869" y="1470212"/>
+            <a:off x="5607449" y="1329700"/>
             <a:ext cx="2421150" cy="2230065"/>
           </a:xfrm>
           <a:prstGeom prst="rect">
@@ -4230,7 +4238,7 @@
         </p:blipFill>
         <p:spPr bwMode="auto">
           <a:xfrm>
-            <a:off x="4245002" y="3400099"/>
+            <a:off x="3881718" y="3651564"/>
             <a:ext cx="5380733" cy="2829224"/>
           </a:xfrm>
           <a:prstGeom prst="rect">
@@ -4295,6 +4303,107 @@
           </a:extLst>
         </p:spPr>
       </p:pic>
+      <p:sp>
+        <p:nvSpPr>
+          <p:cNvPr id="3" name="AutoShape 2" descr="What is SQL Database: Structure, Types, Examples">
+            <a:extLst>
+              <a:ext uri="{FF2B5EF4-FFF2-40B4-BE49-F238E27FC236}">
+                <a16:creationId xmlns:a16="http://schemas.microsoft.com/office/drawing/2014/main" id="{A7E1FE6B-CB41-40F6-8EE4-B1DDDCA276FA}"/>
+              </a:ext>
+            </a:extLst>
+          </p:cNvPr>
+          <p:cNvSpPr>
+            <a:spLocks noChangeAspect="1" noChangeArrowheads="1"/>
+          </p:cNvSpPr>
+          <p:nvPr/>
+        </p:nvSpPr>
+        <p:spPr bwMode="auto">
+          <a:xfrm>
+            <a:off x="5943600" y="3276600"/>
+            <a:ext cx="1987554" cy="1987554"/>
+          </a:xfrm>
+          <a:prstGeom prst="rect">
+            <a:avLst/>
+          </a:prstGeom>
+          <a:noFill/>
+          <a:extLst>
+            <a:ext uri="{909E8E84-426E-40DD-AFC4-6F175D3DCCD1}">
+              <a14:hiddenFill xmlns:a14="http://schemas.microsoft.com/office/drawing/2010/main">
+                <a:solidFill>
+                  <a:srgbClr val="FFFFFF"/>
+                </a:solidFill>
+              </a14:hiddenFill>
+            </a:ext>
+          </a:extLst>
+        </p:spPr>
+        <p:txBody>
+          <a:bodyPr vert="horz" wrap="square" lIns="91440" tIns="45720" rIns="91440" bIns="45720" numCol="1" anchor="t" anchorCtr="0" compatLnSpc="1">
+            <a:prstTxWarp prst="textNoShape">
+              <a:avLst/>
+            </a:prstTxWarp>
+          </a:bodyPr>
+          <a:lstStyle/>
+          <a:p>
+            <a:endParaRPr lang="bg-BG"/>
+          </a:p>
+        </p:txBody>
+      </p:sp>
+      <p:pic>
+        <p:nvPicPr>
+          <p:cNvPr id="1032" name="Picture 8" descr="SQL Database Manager DB-Client - Apps on Google Play">
+            <a:extLst>
+              <a:ext uri="{FF2B5EF4-FFF2-40B4-BE49-F238E27FC236}">
+                <a16:creationId xmlns:a16="http://schemas.microsoft.com/office/drawing/2014/main" id="{A8CE3E3F-4DCC-4363-8087-52195A58EDF1}"/>
+              </a:ext>
+            </a:extLst>
+          </p:cNvPr>
+          <p:cNvPicPr>
+            <a:picLocks noChangeAspect="1" noChangeArrowheads="1"/>
+          </p:cNvPicPr>
+          <p:nvPr/>
+        </p:nvPicPr>
+        <p:blipFill>
+          <a:blip r:embed="rId14">
+            <a:extLst>
+              <a:ext uri="{BEBA8EAE-BF5A-486C-A8C5-ECC9F3942E4B}">
+                <a14:imgProps xmlns:a14="http://schemas.microsoft.com/office/drawing/2010/main">
+                  <a14:imgLayer r:embed="rId15">
+                    <a14:imgEffect>
+                      <a14:backgroundRemoval t="10000" b="90000" l="10000" r="90000"/>
+                    </a14:imgEffect>
+                  </a14:imgLayer>
+                </a14:imgProps>
+              </a:ext>
+              <a:ext uri="{28A0092B-C50C-407E-A947-70E740481C1C}">
+                <a14:useLocalDpi xmlns:a14="http://schemas.microsoft.com/office/drawing/2010/main" val="0"/>
+              </a:ext>
+            </a:extLst>
+          </a:blip>
+          <a:srcRect/>
+          <a:stretch>
+            <a:fillRect/>
+          </a:stretch>
+        </p:blipFill>
+        <p:spPr bwMode="auto">
+          <a:xfrm>
+            <a:off x="7178855" y="1388885"/>
+            <a:ext cx="4634133" cy="2317067"/>
+          </a:xfrm>
+          <a:prstGeom prst="rect">
+            <a:avLst/>
+          </a:prstGeom>
+          <a:noFill/>
+          <a:extLst>
+            <a:ext uri="{909E8E84-426E-40DD-AFC4-6F175D3DCCD1}">
+              <a14:hiddenFill xmlns:a14="http://schemas.microsoft.com/office/drawing/2010/main">
+                <a:solidFill>
+                  <a:srgbClr val="FFFFFF"/>
+                </a:solidFill>
+              </a14:hiddenFill>
+            </a:ext>
+          </a:extLst>
+        </p:spPr>
+      </p:pic>
     </p:spTree>
     <p:extLst>
       <p:ext uri="{BB962C8B-B14F-4D97-AF65-F5344CB8AC3E}">
@@ -4309,6 +4418,412 @@
 </file>
 
 <file path=ppt/slides/slide6.xml><?xml version="1.0" encoding="utf-8"?>
+<p:sld xmlns:a="http://schemas.openxmlformats.org/drawingml/2006/main" xmlns:r="http://schemas.openxmlformats.org/officeDocument/2006/relationships" xmlns:p="http://schemas.openxmlformats.org/presentationml/2006/main">
+  <p:cSld>
+    <p:spTree>
+      <p:nvGrpSpPr>
+        <p:cNvPr id="1" name=""/>
+        <p:cNvGrpSpPr/>
+        <p:nvPr/>
+      </p:nvGrpSpPr>
+      <p:grpSpPr>
+        <a:xfrm>
+          <a:off x="0" y="0"/>
+          <a:ext cx="0" cy="0"/>
+          <a:chOff x="0" y="0"/>
+          <a:chExt cx="0" cy="0"/>
+        </a:xfrm>
+      </p:grpSpPr>
+      <p:sp>
+        <p:nvSpPr>
+          <p:cNvPr id="2" name="Title 1">
+            <a:extLst>
+              <a:ext uri="{FF2B5EF4-FFF2-40B4-BE49-F238E27FC236}">
+                <a16:creationId xmlns:a16="http://schemas.microsoft.com/office/drawing/2014/main" id="{B1590F9D-8DE4-4A7B-B027-089CCFE35091}"/>
+              </a:ext>
+            </a:extLst>
+          </p:cNvPr>
+          <p:cNvSpPr>
+            <a:spLocks noGrp="1"/>
+          </p:cNvSpPr>
+          <p:nvPr>
+            <p:ph type="title"/>
+          </p:nvPr>
+        </p:nvSpPr>
+        <p:spPr/>
+        <p:txBody>
+          <a:bodyPr/>
+          <a:lstStyle/>
+          <a:p>
+            <a:r>
+              <a:rPr lang="en-150" dirty="0"/>
+              <a:t>Architecture</a:t>
+            </a:r>
+            <a:endParaRPr lang="bg-BG" dirty="0"/>
+          </a:p>
+        </p:txBody>
+      </p:sp>
+      <p:sp>
+        <p:nvSpPr>
+          <p:cNvPr id="3" name="Content Placeholder 2">
+            <a:extLst>
+              <a:ext uri="{FF2B5EF4-FFF2-40B4-BE49-F238E27FC236}">
+                <a16:creationId xmlns:a16="http://schemas.microsoft.com/office/drawing/2014/main" id="{6F7C2ED1-1F75-4420-B77A-AFE0B0A04A73}"/>
+              </a:ext>
+            </a:extLst>
+          </p:cNvPr>
+          <p:cNvSpPr>
+            <a:spLocks noGrp="1"/>
+          </p:cNvSpPr>
+          <p:nvPr>
+            <p:ph idx="1"/>
+          </p:nvPr>
+        </p:nvSpPr>
+        <p:spPr/>
+        <p:txBody>
+          <a:bodyPr/>
+          <a:lstStyle/>
+          <a:p>
+            <a:r>
+              <a:rPr lang="en-150" b="1" dirty="0"/>
+              <a:t>Models</a:t>
+            </a:r>
+            <a:r>
+              <a:rPr lang="en-150" dirty="0"/>
+              <a:t>: Trip, Booking, </a:t>
+            </a:r>
+            <a:r>
+              <a:rPr lang="en-150" dirty="0" err="1"/>
+              <a:t>ApplicationUser</a:t>
+            </a:r>
+            <a:endParaRPr lang="en-150" dirty="0"/>
+          </a:p>
+          <a:p>
+            <a:r>
+              <a:rPr lang="en-150" b="1" dirty="0"/>
+              <a:t>Controllers</a:t>
+            </a:r>
+            <a:r>
+              <a:rPr lang="en-150" dirty="0"/>
+              <a:t>: </a:t>
+            </a:r>
+            <a:r>
+              <a:rPr lang="en-150" dirty="0" err="1"/>
+              <a:t>TripController</a:t>
+            </a:r>
+            <a:r>
+              <a:rPr lang="en-150" dirty="0"/>
+              <a:t>, </a:t>
+            </a:r>
+            <a:r>
+              <a:rPr lang="en-150" dirty="0" err="1"/>
+              <a:t>BookingController</a:t>
+            </a:r>
+            <a:r>
+              <a:rPr lang="en-150" dirty="0"/>
+              <a:t>, </a:t>
+            </a:r>
+            <a:r>
+              <a:rPr lang="en-150" dirty="0" err="1"/>
+              <a:t>AccountController</a:t>
+            </a:r>
+            <a:endParaRPr lang="en-150" dirty="0"/>
+          </a:p>
+          <a:p>
+            <a:r>
+              <a:rPr lang="en-150" b="1" dirty="0"/>
+              <a:t>Views</a:t>
+            </a:r>
+            <a:r>
+              <a:rPr lang="en-150" dirty="0"/>
+              <a:t>: Razor pages for each feature</a:t>
+            </a:r>
+          </a:p>
+          <a:p>
+            <a:r>
+              <a:rPr lang="en-150" b="1" dirty="0"/>
+              <a:t>Database</a:t>
+            </a:r>
+            <a:r>
+              <a:rPr lang="en-150" dirty="0"/>
+              <a:t>: EF Core Code‑First with migrations</a:t>
+            </a:r>
+          </a:p>
+          <a:p>
+            <a:r>
+              <a:rPr lang="en-150" b="1" dirty="0"/>
+              <a:t>Identity</a:t>
+            </a:r>
+            <a:r>
+              <a:rPr lang="en-150" dirty="0"/>
+              <a:t>: User accounts and roles</a:t>
+            </a:r>
+            <a:endParaRPr lang="bg-BG" dirty="0"/>
+          </a:p>
+        </p:txBody>
+      </p:sp>
+    </p:spTree>
+    <p:extLst>
+      <p:ext uri="{BB962C8B-B14F-4D97-AF65-F5344CB8AC3E}">
+        <p14:creationId xmlns:p14="http://schemas.microsoft.com/office/powerpoint/2010/main" val="2557704846"/>
+      </p:ext>
+    </p:extLst>
+  </p:cSld>
+  <p:clrMapOvr>
+    <a:masterClrMapping/>
+  </p:clrMapOvr>
+</p:sld>
+</file>
+
+<file path=ppt/slides/slide7.xml><?xml version="1.0" encoding="utf-8"?>
+<p:sld xmlns:a="http://schemas.openxmlformats.org/drawingml/2006/main" xmlns:r="http://schemas.openxmlformats.org/officeDocument/2006/relationships" xmlns:p="http://schemas.openxmlformats.org/presentationml/2006/main">
+  <p:cSld>
+    <p:spTree>
+      <p:nvGrpSpPr>
+        <p:cNvPr id="1" name=""/>
+        <p:cNvGrpSpPr/>
+        <p:nvPr/>
+      </p:nvGrpSpPr>
+      <p:grpSpPr>
+        <a:xfrm>
+          <a:off x="0" y="0"/>
+          <a:ext cx="0" cy="0"/>
+          <a:chOff x="0" y="0"/>
+          <a:chExt cx="0" cy="0"/>
+        </a:xfrm>
+      </p:grpSpPr>
+      <p:sp>
+        <p:nvSpPr>
+          <p:cNvPr id="2" name="Title 1">
+            <a:extLst>
+              <a:ext uri="{FF2B5EF4-FFF2-40B4-BE49-F238E27FC236}">
+                <a16:creationId xmlns:a16="http://schemas.microsoft.com/office/drawing/2014/main" id="{A4641BCF-BA48-4FE3-8151-B2EA0B0FEB98}"/>
+              </a:ext>
+            </a:extLst>
+          </p:cNvPr>
+          <p:cNvSpPr>
+            <a:spLocks noGrp="1"/>
+          </p:cNvSpPr>
+          <p:nvPr>
+            <p:ph type="title"/>
+          </p:nvPr>
+        </p:nvSpPr>
+        <p:spPr/>
+        <p:txBody>
+          <a:bodyPr/>
+          <a:lstStyle/>
+          <a:p>
+            <a:r>
+              <a:rPr lang="en-150" dirty="0"/>
+              <a:t>How It Works</a:t>
+            </a:r>
+            <a:endParaRPr lang="bg-BG" dirty="0"/>
+          </a:p>
+        </p:txBody>
+      </p:sp>
+      <p:sp>
+        <p:nvSpPr>
+          <p:cNvPr id="3" name="Content Placeholder 2">
+            <a:extLst>
+              <a:ext uri="{FF2B5EF4-FFF2-40B4-BE49-F238E27FC236}">
+                <a16:creationId xmlns:a16="http://schemas.microsoft.com/office/drawing/2014/main" id="{98E758AC-06D6-4C84-9CF2-21A66E2082BA}"/>
+              </a:ext>
+            </a:extLst>
+          </p:cNvPr>
+          <p:cNvSpPr>
+            <a:spLocks noGrp="1"/>
+          </p:cNvSpPr>
+          <p:nvPr>
+            <p:ph idx="1"/>
+          </p:nvPr>
+        </p:nvSpPr>
+        <p:spPr/>
+        <p:txBody>
+          <a:bodyPr/>
+          <a:lstStyle/>
+          <a:p>
+            <a:r>
+              <a:rPr lang="en-150" dirty="0"/>
+              <a:t>User logs in</a:t>
+            </a:r>
+          </a:p>
+          <a:p>
+            <a:r>
+              <a:rPr lang="en-150" dirty="0"/>
+              <a:t>User sees available trips</a:t>
+            </a:r>
+          </a:p>
+          <a:p>
+            <a:r>
+              <a:rPr lang="en-150" dirty="0"/>
+              <a:t>User searches by date or destination</a:t>
+            </a:r>
+          </a:p>
+          <a:p>
+            <a:r>
+              <a:rPr lang="en-150" dirty="0"/>
+              <a:t>User opens trip details</a:t>
+            </a:r>
+          </a:p>
+          <a:p>
+            <a:r>
+              <a:rPr lang="en-150" dirty="0"/>
+              <a:t>User books seats</a:t>
+            </a:r>
+          </a:p>
+          <a:p>
+            <a:r>
+              <a:rPr lang="en-150" dirty="0"/>
+              <a:t>Driver sees bookings</a:t>
+            </a:r>
+            <a:endParaRPr lang="bg-BG" dirty="0"/>
+          </a:p>
+        </p:txBody>
+      </p:sp>
+    </p:spTree>
+    <p:extLst>
+      <p:ext uri="{BB962C8B-B14F-4D97-AF65-F5344CB8AC3E}">
+        <p14:creationId xmlns:p14="http://schemas.microsoft.com/office/powerpoint/2010/main" val="1102151556"/>
+      </p:ext>
+    </p:extLst>
+  </p:cSld>
+  <p:clrMapOvr>
+    <a:masterClrMapping/>
+  </p:clrMapOvr>
+</p:sld>
+</file>
+
+<file path=ppt/slides/slide8.xml><?xml version="1.0" encoding="utf-8"?>
+<p:sld xmlns:a="http://schemas.openxmlformats.org/drawingml/2006/main" xmlns:r="http://schemas.openxmlformats.org/officeDocument/2006/relationships" xmlns:p="http://schemas.openxmlformats.org/presentationml/2006/main">
+  <p:cSld>
+    <p:spTree>
+      <p:nvGrpSpPr>
+        <p:cNvPr id="1" name=""/>
+        <p:cNvGrpSpPr/>
+        <p:nvPr/>
+      </p:nvGrpSpPr>
+      <p:grpSpPr>
+        <a:xfrm>
+          <a:off x="0" y="0"/>
+          <a:ext cx="0" cy="0"/>
+          <a:chOff x="0" y="0"/>
+          <a:chExt cx="0" cy="0"/>
+        </a:xfrm>
+      </p:grpSpPr>
+      <p:sp>
+        <p:nvSpPr>
+          <p:cNvPr id="2" name="Title 1">
+            <a:extLst>
+              <a:ext uri="{FF2B5EF4-FFF2-40B4-BE49-F238E27FC236}">
+                <a16:creationId xmlns:a16="http://schemas.microsoft.com/office/drawing/2014/main" id="{5005BF7E-2644-449D-B4E1-9A54C5EA1042}"/>
+              </a:ext>
+            </a:extLst>
+          </p:cNvPr>
+          <p:cNvSpPr>
+            <a:spLocks noGrp="1"/>
+          </p:cNvSpPr>
+          <p:nvPr>
+            <p:ph type="title"/>
+          </p:nvPr>
+        </p:nvSpPr>
+        <p:spPr/>
+        <p:txBody>
+          <a:bodyPr/>
+          <a:lstStyle/>
+          <a:p>
+            <a:r>
+              <a:rPr lang="en-150" dirty="0"/>
+              <a:t>Trip Creation</a:t>
+            </a:r>
+            <a:endParaRPr lang="bg-BG" dirty="0"/>
+          </a:p>
+        </p:txBody>
+      </p:sp>
+      <p:sp>
+        <p:nvSpPr>
+          <p:cNvPr id="3" name="Content Placeholder 2">
+            <a:extLst>
+              <a:ext uri="{FF2B5EF4-FFF2-40B4-BE49-F238E27FC236}">
+                <a16:creationId xmlns:a16="http://schemas.microsoft.com/office/drawing/2014/main" id="{76C96C69-BC14-437C-80F1-CF7905CAB915}"/>
+              </a:ext>
+            </a:extLst>
+          </p:cNvPr>
+          <p:cNvSpPr>
+            <a:spLocks noGrp="1"/>
+          </p:cNvSpPr>
+          <p:nvPr>
+            <p:ph idx="1"/>
+          </p:nvPr>
+        </p:nvSpPr>
+        <p:spPr/>
+        <p:txBody>
+          <a:bodyPr/>
+          <a:lstStyle/>
+          <a:p>
+            <a:r>
+              <a:rPr lang="en-US" dirty="0"/>
+              <a:t>A trip contains:</a:t>
+            </a:r>
+            <a:endParaRPr lang="en-150" dirty="0"/>
+          </a:p>
+          <a:p>
+            <a:r>
+              <a:rPr lang="en-US" dirty="0"/>
+              <a:t>Start location</a:t>
+            </a:r>
+            <a:endParaRPr lang="en-150" dirty="0"/>
+          </a:p>
+          <a:p>
+            <a:r>
+              <a:rPr lang="en-US" dirty="0"/>
+              <a:t>End location</a:t>
+            </a:r>
+            <a:endParaRPr lang="en-150" dirty="0"/>
+          </a:p>
+          <a:p>
+            <a:r>
+              <a:rPr lang="en-US" dirty="0"/>
+              <a:t>Date</a:t>
+            </a:r>
+            <a:endParaRPr lang="en-150" dirty="0"/>
+          </a:p>
+          <a:p>
+            <a:r>
+              <a:rPr lang="en-US" dirty="0"/>
+              <a:t>Time</a:t>
+            </a:r>
+            <a:endParaRPr lang="en-150" dirty="0"/>
+          </a:p>
+          <a:p>
+            <a:r>
+              <a:rPr lang="en-US" dirty="0"/>
+              <a:t>Available seats</a:t>
+            </a:r>
+            <a:endParaRPr lang="en-150" dirty="0"/>
+          </a:p>
+          <a:p>
+            <a:r>
+              <a:rPr lang="en-US" dirty="0"/>
+              <a:t>Driver (logged-in user)</a:t>
+            </a:r>
+            <a:endParaRPr lang="bg-BG" dirty="0"/>
+          </a:p>
+        </p:txBody>
+      </p:sp>
+    </p:spTree>
+    <p:extLst>
+      <p:ext uri="{BB962C8B-B14F-4D97-AF65-F5344CB8AC3E}">
+        <p14:creationId xmlns:p14="http://schemas.microsoft.com/office/powerpoint/2010/main" val="772274258"/>
+      </p:ext>
+    </p:extLst>
+  </p:cSld>
+  <p:clrMapOvr>
+    <a:masterClrMapping/>
+  </p:clrMapOvr>
+</p:sld>
+</file>
+
+<file path=ppt/slides/slide9.xml><?xml version="1.0" encoding="utf-8"?>
 <p:sld xmlns:a="http://schemas.openxmlformats.org/drawingml/2006/main" xmlns:r="http://schemas.openxmlformats.org/officeDocument/2006/relationships" xmlns:p="http://schemas.openxmlformats.org/presentationml/2006/main">
   <p:cSld>
     <p:spTree>
@@ -4629,25 +5144,7 @@
                 </a:solidFill>
                 <a:latin typeface="Agency FB"/>
               </a:rPr>
-              <a:t>Let’s go to </a:t>
-            </a:r>
-            <a:r>
-              <a:rPr lang="en-150" sz="9600" spc="-1" dirty="0" err="1">
-                <a:solidFill>
-                  <a:srgbClr val="FF914D"/>
-                </a:solidFill>
-                <a:latin typeface="Agency FB"/>
-              </a:rPr>
-              <a:t>th</a:t>
-            </a:r>
-            <a:r>
-              <a:rPr lang="en-150" sz="9600" spc="-1" dirty="0">
-                <a:solidFill>
-                  <a:srgbClr val="FF914D"/>
-                </a:solidFill>
-                <a:latin typeface="Agency FB"/>
-              </a:rPr>
-              <a:t> application</a:t>
+              <a:t>Let’s go to the application</a:t>
             </a:r>
             <a:endParaRPr lang="en-US" sz="9600" b="0" strike="noStrike" spc="-1" dirty="0">
               <a:solidFill>

</xml_diff>